<commit_message>
Rebuild LPN flowchart layout with consistent grid and no line crossings
Apply standard flowchart conventions: main flow proceeds straight
across one row, every YES/resolved branch drops to the row directly
below, and each independent case sits in its own isolated lane so no
connector lines cross.

Co-Authored-By: Claude Sonnet 4.6 <noreply@anthropic.com>
Claude-Session: https://claude.ai/code/session_014LN5dU5LtPSyG4iXygZNs3
</commit_message>
<xml_diff>
--- a/LPN分割_誤り対応フロー.pptx
+++ b/LPN分割_誤り対応フロー.pptx
@@ -3127,8 +3127,8 @@
         </p:nvSpPr>
         <p:spPr>
           <a:xfrm>
-            <a:off x="365760" y="822960"/>
-            <a:ext cx="2468880" cy="822960"/>
+            <a:off x="274320" y="640080"/>
+            <a:ext cx="2103120" cy="914400"/>
           </a:xfrm>
           <a:prstGeom prst="roundRect">
             <a:avLst/>
@@ -3163,7 +3163,7 @@
           <a:p>
             <a:pPr algn="ctr"/>
             <a:r>
-              <a:rPr sz="1400" b="0">
+              <a:rPr sz="1300" b="0">
                 <a:solidFill>
                   <a:srgbClr val="000000"/>
                 </a:solidFill>
@@ -3177,14 +3177,180 @@
       </p:sp>
       <p:sp>
         <p:nvSpPr>
-          <p:cNvPr id="4" name="Rounded Rectangle 3"/>
+          <p:cNvPr id="4" name="Diamond 3"/>
           <p:cNvSpPr/>
           <p:nvPr/>
         </p:nvSpPr>
         <p:spPr>
           <a:xfrm>
-            <a:off x="365760" y="1965960"/>
-            <a:ext cx="2468880" cy="822960"/>
+            <a:off x="3017520" y="548640"/>
+            <a:ext cx="1554480" cy="1097280"/>
+          </a:xfrm>
+          <a:prstGeom prst="diamond">
+            <a:avLst/>
+          </a:prstGeom>
+          <a:solidFill>
+            <a:srgbClr val="FFE699"/>
+          </a:solidFill>
+          <a:ln w="15875">
+            <a:solidFill>
+              <a:srgbClr val="404040"/>
+            </a:solidFill>
+          </a:ln>
+          <a:effectLst/>
+        </p:spPr>
+        <p:style>
+          <a:lnRef idx="1">
+            <a:schemeClr val="accent1"/>
+          </a:lnRef>
+          <a:fillRef idx="3">
+            <a:schemeClr val="accent1"/>
+          </a:fillRef>
+          <a:effectRef idx="2">
+            <a:schemeClr val="accent1"/>
+          </a:effectRef>
+          <a:fontRef idx="minor">
+            <a:schemeClr val="lt1"/>
+          </a:fontRef>
+        </p:style>
+        <p:txBody>
+          <a:bodyPr rtlCol="0" anchor="ctr" wrap="square" lIns="45720" rIns="45720" tIns="18288" bIns="18288"/>
+          <a:lstStyle/>
+          <a:p>
+            <a:pPr algn="ctr"/>
+            <a:r>
+              <a:rPr sz="1300" b="0">
+                <a:solidFill>
+                  <a:srgbClr val="000000"/>
+                </a:solidFill>
+                <a:latin typeface="メイリオ"/>
+              </a:rPr>
+              <a:t>即出荷後に
+LPN分割したか？</a:t>
+            </a:r>
+          </a:p>
+        </p:txBody>
+      </p:sp>
+      <p:sp>
+        <p:nvSpPr>
+          <p:cNvPr id="5" name="Diamond 4"/>
+          <p:cNvSpPr/>
+          <p:nvPr/>
+        </p:nvSpPr>
+        <p:spPr>
+          <a:xfrm>
+            <a:off x="6675120" y="548640"/>
+            <a:ext cx="1463040" cy="1097280"/>
+          </a:xfrm>
+          <a:prstGeom prst="diamond">
+            <a:avLst/>
+          </a:prstGeom>
+          <a:solidFill>
+            <a:srgbClr val="FFE699"/>
+          </a:solidFill>
+          <a:ln w="15875">
+            <a:solidFill>
+              <a:srgbClr val="404040"/>
+            </a:solidFill>
+          </a:ln>
+          <a:effectLst/>
+        </p:spPr>
+        <p:style>
+          <a:lnRef idx="1">
+            <a:schemeClr val="accent1"/>
+          </a:lnRef>
+          <a:fillRef idx="3">
+            <a:schemeClr val="accent1"/>
+          </a:fillRef>
+          <a:effectRef idx="2">
+            <a:schemeClr val="accent1"/>
+          </a:effectRef>
+          <a:fontRef idx="minor">
+            <a:schemeClr val="lt1"/>
+          </a:fontRef>
+        </p:style>
+        <p:txBody>
+          <a:bodyPr rtlCol="0" anchor="ctr" wrap="square" lIns="45720" rIns="45720" tIns="18288" bIns="18288"/>
+          <a:lstStyle/>
+          <a:p>
+            <a:pPr algn="ctr"/>
+            <a:r>
+              <a:rPr sz="1400" b="0">
+                <a:solidFill>
+                  <a:srgbClr val="000000"/>
+                </a:solidFill>
+                <a:latin typeface="メイリオ"/>
+              </a:rPr>
+              <a:t>1RECか？</a:t>
+            </a:r>
+          </a:p>
+        </p:txBody>
+      </p:sp>
+      <p:sp>
+        <p:nvSpPr>
+          <p:cNvPr id="6" name="Rounded Rectangle 5"/>
+          <p:cNvSpPr/>
+          <p:nvPr/>
+        </p:nvSpPr>
+        <p:spPr>
+          <a:xfrm>
+            <a:off x="3017520" y="2011680"/>
+            <a:ext cx="1554480" cy="731520"/>
+          </a:xfrm>
+          <a:prstGeom prst="roundRect">
+            <a:avLst/>
+          </a:prstGeom>
+          <a:solidFill>
+            <a:srgbClr val="DDEBF7"/>
+          </a:solidFill>
+          <a:ln w="15875">
+            <a:solidFill>
+              <a:srgbClr val="404040"/>
+            </a:solidFill>
+          </a:ln>
+          <a:effectLst/>
+        </p:spPr>
+        <p:style>
+          <a:lnRef idx="1">
+            <a:schemeClr val="accent1"/>
+          </a:lnRef>
+          <a:fillRef idx="3">
+            <a:schemeClr val="accent1"/>
+          </a:fillRef>
+          <a:effectRef idx="2">
+            <a:schemeClr val="accent1"/>
+          </a:effectRef>
+          <a:fontRef idx="minor">
+            <a:schemeClr val="lt1"/>
+          </a:fontRef>
+        </p:style>
+        <p:txBody>
+          <a:bodyPr rtlCol="0" anchor="ctr" wrap="square" lIns="45720" rIns="45720" tIns="18288" bIns="18288"/>
+          <a:lstStyle/>
+          <a:p>
+            <a:pPr algn="ctr"/>
+            <a:r>
+              <a:rPr sz="1400" b="1">
+                <a:solidFill>
+                  <a:srgbClr val="000000"/>
+                </a:solidFill>
+                <a:latin typeface="メイリオ"/>
+              </a:rPr>
+              <a:t>oLPN統合</a:t>
+            </a:r>
+          </a:p>
+        </p:txBody>
+      </p:sp>
+      <p:sp>
+        <p:nvSpPr>
+          <p:cNvPr id="7" name="Rounded Rectangle 6"/>
+          <p:cNvSpPr/>
+          <p:nvPr/>
+        </p:nvSpPr>
+        <p:spPr>
+          <a:xfrm>
+            <a:off x="274320" y="2011680"/>
+            <a:ext cx="2103120" cy="731520"/>
           </a:xfrm>
           <a:prstGeom prst="roundRect">
             <a:avLst/>
@@ -3219,7 +3385,7 @@
           <a:p>
             <a:pPr algn="ctr"/>
             <a:r>
-              <a:rPr sz="1400" b="0">
+              <a:rPr sz="1300" b="0">
                 <a:solidFill>
                   <a:srgbClr val="000000"/>
                 </a:solidFill>
@@ -3233,14 +3399,125 @@
       </p:sp>
       <p:sp>
         <p:nvSpPr>
-          <p:cNvPr id="5" name="Rounded Rectangle 4"/>
+          <p:cNvPr id="8" name="Rounded Rectangle 7"/>
           <p:cNvSpPr/>
           <p:nvPr/>
         </p:nvSpPr>
         <p:spPr>
           <a:xfrm>
-            <a:off x="365760" y="3520440"/>
-            <a:ext cx="2468880" cy="822960"/>
+            <a:off x="5669280" y="2011680"/>
+            <a:ext cx="1645920" cy="731520"/>
+          </a:xfrm>
+          <a:prstGeom prst="roundRect">
+            <a:avLst/>
+          </a:prstGeom>
+          <a:solidFill>
+            <a:srgbClr val="DDEBF7"/>
+          </a:solidFill>
+          <a:ln w="15875">
+            <a:solidFill>
+              <a:srgbClr val="404040"/>
+            </a:solidFill>
+          </a:ln>
+          <a:effectLst/>
+        </p:spPr>
+        <p:style>
+          <a:lnRef idx="1">
+            <a:schemeClr val="accent1"/>
+          </a:lnRef>
+          <a:fillRef idx="3">
+            <a:schemeClr val="accent1"/>
+          </a:fillRef>
+          <a:effectRef idx="2">
+            <a:schemeClr val="accent1"/>
+          </a:effectRef>
+          <a:fontRef idx="minor">
+            <a:schemeClr val="lt1"/>
+          </a:fontRef>
+        </p:style>
+        <p:txBody>
+          <a:bodyPr rtlCol="0" anchor="ctr" wrap="square" lIns="45720" rIns="45720" tIns="18288" bIns="18288"/>
+          <a:lstStyle/>
+          <a:p>
+            <a:pPr algn="ctr"/>
+            <a:r>
+              <a:rPr sz="1300" b="1">
+                <a:solidFill>
+                  <a:srgbClr val="000000"/>
+                </a:solidFill>
+                <a:latin typeface="メイリオ"/>
+              </a:rPr>
+              <a:t>国内梱包_1REC</a:t>
+            </a:r>
+          </a:p>
+        </p:txBody>
+      </p:sp>
+      <p:sp>
+        <p:nvSpPr>
+          <p:cNvPr id="9" name="Rounded Rectangle 8"/>
+          <p:cNvSpPr/>
+          <p:nvPr/>
+        </p:nvSpPr>
+        <p:spPr>
+          <a:xfrm>
+            <a:off x="7772400" y="2011680"/>
+            <a:ext cx="2377440" cy="731520"/>
+          </a:xfrm>
+          <a:prstGeom prst="roundRect">
+            <a:avLst/>
+          </a:prstGeom>
+          <a:solidFill>
+            <a:srgbClr val="DDEBF7"/>
+          </a:solidFill>
+          <a:ln w="15875">
+            <a:solidFill>
+              <a:srgbClr val="404040"/>
+            </a:solidFill>
+          </a:ln>
+          <a:effectLst/>
+        </p:spPr>
+        <p:style>
+          <a:lnRef idx="1">
+            <a:schemeClr val="accent1"/>
+          </a:lnRef>
+          <a:fillRef idx="3">
+            <a:schemeClr val="accent1"/>
+          </a:fillRef>
+          <a:effectRef idx="2">
+            <a:schemeClr val="accent1"/>
+          </a:effectRef>
+          <a:fontRef idx="minor">
+            <a:schemeClr val="lt1"/>
+          </a:fontRef>
+        </p:style>
+        <p:txBody>
+          <a:bodyPr rtlCol="0" anchor="ctr" wrap="square" lIns="45720" rIns="45720" tIns="18288" bIns="18288"/>
+          <a:lstStyle/>
+          <a:p>
+            <a:pPr algn="ctr"/>
+            <a:r>
+              <a:rPr sz="1200" b="1">
+                <a:solidFill>
+                  <a:srgbClr val="000000"/>
+                </a:solidFill>
+                <a:latin typeface="メイリオ"/>
+              </a:rPr>
+              <a:t>国内梱包_複数REC
+＋イレギュラー置き場へ</a:t>
+            </a:r>
+          </a:p>
+        </p:txBody>
+      </p:sp>
+      <p:sp>
+        <p:nvSpPr>
+          <p:cNvPr id="10" name="Rounded Rectangle 9"/>
+          <p:cNvSpPr/>
+          <p:nvPr/>
+        </p:nvSpPr>
+        <p:spPr>
+          <a:xfrm>
+            <a:off x="274320" y="3200400"/>
+            <a:ext cx="2103120" cy="822960"/>
           </a:xfrm>
           <a:prstGeom prst="roundRect">
             <a:avLst/>
@@ -3275,7 +3552,7 @@
           <a:p>
             <a:pPr algn="ctr"/>
             <a:r>
-              <a:rPr sz="1400" b="0">
+              <a:rPr sz="1300" b="0">
                 <a:solidFill>
                   <a:srgbClr val="000000"/>
                 </a:solidFill>
@@ -3289,14 +3566,69 @@
       </p:sp>
       <p:sp>
         <p:nvSpPr>
-          <p:cNvPr id="6" name="Rounded Rectangle 5"/>
+          <p:cNvPr id="11" name="Rounded Rectangle 10"/>
           <p:cNvSpPr/>
           <p:nvPr/>
         </p:nvSpPr>
         <p:spPr>
           <a:xfrm>
-            <a:off x="365760" y="4617720"/>
-            <a:ext cx="2468880" cy="822960"/>
+            <a:off x="3017520" y="3200400"/>
+            <a:ext cx="2103120" cy="822960"/>
+          </a:xfrm>
+          <a:prstGeom prst="roundRect">
+            <a:avLst/>
+          </a:prstGeom>
+          <a:solidFill>
+            <a:srgbClr val="DDEBF7"/>
+          </a:solidFill>
+          <a:ln w="15875">
+            <a:solidFill>
+              <a:srgbClr val="404040"/>
+            </a:solidFill>
+          </a:ln>
+          <a:effectLst/>
+        </p:spPr>
+        <p:style>
+          <a:lnRef idx="1">
+            <a:schemeClr val="accent1"/>
+          </a:lnRef>
+          <a:fillRef idx="3">
+            <a:schemeClr val="accent1"/>
+          </a:fillRef>
+          <a:effectRef idx="2">
+            <a:schemeClr val="accent1"/>
+          </a:effectRef>
+          <a:fontRef idx="minor">
+            <a:schemeClr val="lt1"/>
+          </a:fontRef>
+        </p:style>
+        <p:txBody>
+          <a:bodyPr rtlCol="0" anchor="ctr" wrap="square" lIns="45720" rIns="45720" tIns="18288" bIns="18288"/>
+          <a:lstStyle/>
+          <a:p>
+            <a:pPr algn="ctr"/>
+            <a:r>
+              <a:rPr sz="1400" b="1">
+                <a:solidFill>
+                  <a:srgbClr val="000000"/>
+                </a:solidFill>
+                <a:latin typeface="メイリオ"/>
+              </a:rPr>
+              <a:t>分割ラベルを使用する</a:t>
+            </a:r>
+          </a:p>
+        </p:txBody>
+      </p:sp>
+      <p:sp>
+        <p:nvSpPr>
+          <p:cNvPr id="12" name="Rounded Rectangle 11"/>
+          <p:cNvSpPr/>
+          <p:nvPr/>
+        </p:nvSpPr>
+        <p:spPr>
+          <a:xfrm>
+            <a:off x="274320" y="4297680"/>
+            <a:ext cx="2103120" cy="822960"/>
           </a:xfrm>
           <a:prstGeom prst="roundRect">
             <a:avLst/>
@@ -3331,7 +3663,7 @@
           <a:p>
             <a:pPr algn="ctr"/>
             <a:r>
-              <a:rPr sz="1400" b="0">
+              <a:rPr sz="1300" b="0">
                 <a:solidFill>
                   <a:srgbClr val="000000"/>
                 </a:solidFill>
@@ -3345,14 +3677,69 @@
       </p:sp>
       <p:sp>
         <p:nvSpPr>
-          <p:cNvPr id="7" name="Rounded Rectangle 6"/>
+          <p:cNvPr id="13" name="Rounded Rectangle 12"/>
           <p:cNvSpPr/>
           <p:nvPr/>
         </p:nvSpPr>
         <p:spPr>
           <a:xfrm>
-            <a:off x="365760" y="5715000"/>
-            <a:ext cx="2468880" cy="822960"/>
+            <a:off x="3017520" y="4297680"/>
+            <a:ext cx="2103120" cy="822960"/>
+          </a:xfrm>
+          <a:prstGeom prst="roundRect">
+            <a:avLst/>
+          </a:prstGeom>
+          <a:solidFill>
+            <a:srgbClr val="DDEBF7"/>
+          </a:solidFill>
+          <a:ln w="15875">
+            <a:solidFill>
+              <a:srgbClr val="404040"/>
+            </a:solidFill>
+          </a:ln>
+          <a:effectLst/>
+        </p:spPr>
+        <p:style>
+          <a:lnRef idx="1">
+            <a:schemeClr val="accent1"/>
+          </a:lnRef>
+          <a:fillRef idx="3">
+            <a:schemeClr val="accent1"/>
+          </a:fillRef>
+          <a:effectRef idx="2">
+            <a:schemeClr val="accent1"/>
+          </a:effectRef>
+          <a:fontRef idx="minor">
+            <a:schemeClr val="lt1"/>
+          </a:fontRef>
+        </p:style>
+        <p:txBody>
+          <a:bodyPr rtlCol="0" anchor="ctr" wrap="square" lIns="45720" rIns="45720" tIns="18288" bIns="18288"/>
+          <a:lstStyle/>
+          <a:p>
+            <a:pPr algn="ctr"/>
+            <a:r>
+              <a:rPr sz="1400" b="1">
+                <a:solidFill>
+                  <a:srgbClr val="000000"/>
+                </a:solidFill>
+                <a:latin typeface="メイリオ"/>
+              </a:rPr>
+              <a:t>親部材集約</a:t>
+            </a:r>
+          </a:p>
+        </p:txBody>
+      </p:sp>
+      <p:sp>
+        <p:nvSpPr>
+          <p:cNvPr id="14" name="Rounded Rectangle 13"/>
+          <p:cNvSpPr/>
+          <p:nvPr/>
+        </p:nvSpPr>
+        <p:spPr>
+          <a:xfrm>
+            <a:off x="274320" y="5394960"/>
+            <a:ext cx="2103120" cy="822960"/>
           </a:xfrm>
           <a:prstGeom prst="roundRect">
             <a:avLst/>
@@ -3387,7 +3774,7 @@
           <a:p>
             <a:pPr algn="ctr"/>
             <a:r>
-              <a:rPr sz="1400" b="0">
+              <a:rPr sz="1300" b="0">
                 <a:solidFill>
                   <a:srgbClr val="000000"/>
                 </a:solidFill>
@@ -3401,70 +3788,14 @@
       </p:sp>
       <p:sp>
         <p:nvSpPr>
-          <p:cNvPr id="8" name="Diamond 7"/>
+          <p:cNvPr id="15" name="Rounded Rectangle 14"/>
           <p:cNvSpPr/>
           <p:nvPr/>
         </p:nvSpPr>
         <p:spPr>
           <a:xfrm>
-            <a:off x="3383280" y="685800"/>
-            <a:ext cx="1828800" cy="1097280"/>
-          </a:xfrm>
-          <a:prstGeom prst="diamond">
-            <a:avLst/>
-          </a:prstGeom>
-          <a:solidFill>
-            <a:srgbClr val="FFE699"/>
-          </a:solidFill>
-          <a:ln w="15875">
-            <a:solidFill>
-              <a:srgbClr val="404040"/>
-            </a:solidFill>
-          </a:ln>
-          <a:effectLst/>
-        </p:spPr>
-        <p:style>
-          <a:lnRef idx="1">
-            <a:schemeClr val="accent1"/>
-          </a:lnRef>
-          <a:fillRef idx="3">
-            <a:schemeClr val="accent1"/>
-          </a:fillRef>
-          <a:effectRef idx="2">
-            <a:schemeClr val="accent1"/>
-          </a:effectRef>
-          <a:fontRef idx="minor">
-            <a:schemeClr val="lt1"/>
-          </a:fontRef>
-        </p:style>
-        <p:txBody>
-          <a:bodyPr rtlCol="0" anchor="ctr" wrap="square" lIns="45720" rIns="45720" tIns="18288" bIns="18288"/>
-          <a:lstStyle/>
-          <a:p>
-            <a:pPr algn="ctr"/>
-            <a:r>
-              <a:rPr sz="1300" b="0">
-                <a:solidFill>
-                  <a:srgbClr val="000000"/>
-                </a:solidFill>
-                <a:latin typeface="メイリオ"/>
-              </a:rPr>
-              <a:t>即出荷後に
-LPN分割したか？</a:t>
-            </a:r>
-          </a:p>
-        </p:txBody>
-      </p:sp>
-      <p:sp>
-        <p:nvSpPr>
-          <p:cNvPr id="9" name="Rounded Rectangle 8"/>
-          <p:cNvSpPr/>
-          <p:nvPr/>
-        </p:nvSpPr>
-        <p:spPr>
-          <a:xfrm>
-            <a:off x="8778240" y="457200"/>
-            <a:ext cx="2377440" cy="777240"/>
+            <a:off x="3017520" y="5394960"/>
+            <a:ext cx="2377440" cy="822960"/>
           </a:xfrm>
           <a:prstGeom prst="roundRect">
             <a:avLst/>
@@ -3505,337 +3836,6 @@
                 </a:solidFill>
                 <a:latin typeface="メイリオ"/>
               </a:rPr>
-              <a:t>oLPN統合</a:t>
-            </a:r>
-          </a:p>
-        </p:txBody>
-      </p:sp>
-      <p:sp>
-        <p:nvSpPr>
-          <p:cNvPr id="10" name="Diamond 9"/>
-          <p:cNvSpPr/>
-          <p:nvPr/>
-        </p:nvSpPr>
-        <p:spPr>
-          <a:xfrm>
-            <a:off x="5760720" y="1828800"/>
-            <a:ext cx="1645920" cy="1097280"/>
-          </a:xfrm>
-          <a:prstGeom prst="diamond">
-            <a:avLst/>
-          </a:prstGeom>
-          <a:solidFill>
-            <a:srgbClr val="FFE699"/>
-          </a:solidFill>
-          <a:ln w="15875">
-            <a:solidFill>
-              <a:srgbClr val="404040"/>
-            </a:solidFill>
-          </a:ln>
-          <a:effectLst/>
-        </p:spPr>
-        <p:style>
-          <a:lnRef idx="1">
-            <a:schemeClr val="accent1"/>
-          </a:lnRef>
-          <a:fillRef idx="3">
-            <a:schemeClr val="accent1"/>
-          </a:fillRef>
-          <a:effectRef idx="2">
-            <a:schemeClr val="accent1"/>
-          </a:effectRef>
-          <a:fontRef idx="minor">
-            <a:schemeClr val="lt1"/>
-          </a:fontRef>
-        </p:style>
-        <p:txBody>
-          <a:bodyPr rtlCol="0" anchor="ctr" wrap="square" lIns="45720" rIns="45720" tIns="18288" bIns="18288"/>
-          <a:lstStyle/>
-          <a:p>
-            <a:pPr algn="ctr"/>
-            <a:r>
-              <a:rPr sz="1400" b="0">
-                <a:solidFill>
-                  <a:srgbClr val="000000"/>
-                </a:solidFill>
-                <a:latin typeface="メイリオ"/>
-              </a:rPr>
-              <a:t>1RECか？</a:t>
-            </a:r>
-          </a:p>
-        </p:txBody>
-      </p:sp>
-      <p:sp>
-        <p:nvSpPr>
-          <p:cNvPr id="11" name="Rounded Rectangle 10"/>
-          <p:cNvSpPr/>
-          <p:nvPr/>
-        </p:nvSpPr>
-        <p:spPr>
-          <a:xfrm>
-            <a:off x="8778240" y="1600200"/>
-            <a:ext cx="2377440" cy="777240"/>
-          </a:xfrm>
-          <a:prstGeom prst="roundRect">
-            <a:avLst/>
-          </a:prstGeom>
-          <a:solidFill>
-            <a:srgbClr val="DDEBF7"/>
-          </a:solidFill>
-          <a:ln w="15875">
-            <a:solidFill>
-              <a:srgbClr val="404040"/>
-            </a:solidFill>
-          </a:ln>
-          <a:effectLst/>
-        </p:spPr>
-        <p:style>
-          <a:lnRef idx="1">
-            <a:schemeClr val="accent1"/>
-          </a:lnRef>
-          <a:fillRef idx="3">
-            <a:schemeClr val="accent1"/>
-          </a:fillRef>
-          <a:effectRef idx="2">
-            <a:schemeClr val="accent1"/>
-          </a:effectRef>
-          <a:fontRef idx="minor">
-            <a:schemeClr val="lt1"/>
-          </a:fontRef>
-        </p:style>
-        <p:txBody>
-          <a:bodyPr rtlCol="0" anchor="ctr" wrap="square" lIns="45720" rIns="45720" tIns="18288" bIns="18288"/>
-          <a:lstStyle/>
-          <a:p>
-            <a:pPr algn="ctr"/>
-            <a:r>
-              <a:rPr sz="1400" b="1">
-                <a:solidFill>
-                  <a:srgbClr val="000000"/>
-                </a:solidFill>
-                <a:latin typeface="メイリオ"/>
-              </a:rPr>
-              <a:t>国内梱包_1REC</a:t>
-            </a:r>
-          </a:p>
-        </p:txBody>
-      </p:sp>
-      <p:sp>
-        <p:nvSpPr>
-          <p:cNvPr id="12" name="Rounded Rectangle 11"/>
-          <p:cNvSpPr/>
-          <p:nvPr/>
-        </p:nvSpPr>
-        <p:spPr>
-          <a:xfrm>
-            <a:off x="8778240" y="2743200"/>
-            <a:ext cx="2651760" cy="914400"/>
-          </a:xfrm>
-          <a:prstGeom prst="roundRect">
-            <a:avLst/>
-          </a:prstGeom>
-          <a:solidFill>
-            <a:srgbClr val="DDEBF7"/>
-          </a:solidFill>
-          <a:ln w="15875">
-            <a:solidFill>
-              <a:srgbClr val="404040"/>
-            </a:solidFill>
-          </a:ln>
-          <a:effectLst/>
-        </p:spPr>
-        <p:style>
-          <a:lnRef idx="1">
-            <a:schemeClr val="accent1"/>
-          </a:lnRef>
-          <a:fillRef idx="3">
-            <a:schemeClr val="accent1"/>
-          </a:fillRef>
-          <a:effectRef idx="2">
-            <a:schemeClr val="accent1"/>
-          </a:effectRef>
-          <a:fontRef idx="minor">
-            <a:schemeClr val="lt1"/>
-          </a:fontRef>
-        </p:style>
-        <p:txBody>
-          <a:bodyPr rtlCol="0" anchor="ctr" wrap="square" lIns="45720" rIns="45720" tIns="18288" bIns="18288"/>
-          <a:lstStyle/>
-          <a:p>
-            <a:pPr algn="ctr"/>
-            <a:r>
-              <a:rPr sz="1300" b="1">
-                <a:solidFill>
-                  <a:srgbClr val="000000"/>
-                </a:solidFill>
-                <a:latin typeface="メイリオ"/>
-              </a:rPr>
-              <a:t>国内梱包_複数REC
-＋イレギュラー置き場へ</a:t>
-            </a:r>
-          </a:p>
-        </p:txBody>
-      </p:sp>
-      <p:sp>
-        <p:nvSpPr>
-          <p:cNvPr id="13" name="Rounded Rectangle 12"/>
-          <p:cNvSpPr/>
-          <p:nvPr/>
-        </p:nvSpPr>
-        <p:spPr>
-          <a:xfrm>
-            <a:off x="3657600" y="3520440"/>
-            <a:ext cx="2926080" cy="822960"/>
-          </a:xfrm>
-          <a:prstGeom prst="roundRect">
-            <a:avLst/>
-          </a:prstGeom>
-          <a:solidFill>
-            <a:srgbClr val="DDEBF7"/>
-          </a:solidFill>
-          <a:ln w="15875">
-            <a:solidFill>
-              <a:srgbClr val="404040"/>
-            </a:solidFill>
-          </a:ln>
-          <a:effectLst/>
-        </p:spPr>
-        <p:style>
-          <a:lnRef idx="1">
-            <a:schemeClr val="accent1"/>
-          </a:lnRef>
-          <a:fillRef idx="3">
-            <a:schemeClr val="accent1"/>
-          </a:fillRef>
-          <a:effectRef idx="2">
-            <a:schemeClr val="accent1"/>
-          </a:effectRef>
-          <a:fontRef idx="minor">
-            <a:schemeClr val="lt1"/>
-          </a:fontRef>
-        </p:style>
-        <p:txBody>
-          <a:bodyPr rtlCol="0" anchor="ctr" wrap="square" lIns="45720" rIns="45720" tIns="18288" bIns="18288"/>
-          <a:lstStyle/>
-          <a:p>
-            <a:pPr algn="ctr"/>
-            <a:r>
-              <a:rPr sz="1400" b="1">
-                <a:solidFill>
-                  <a:srgbClr val="000000"/>
-                </a:solidFill>
-                <a:latin typeface="メイリオ"/>
-              </a:rPr>
-              <a:t>分割ラベルを使用する</a:t>
-            </a:r>
-          </a:p>
-        </p:txBody>
-      </p:sp>
-      <p:sp>
-        <p:nvSpPr>
-          <p:cNvPr id="14" name="Rounded Rectangle 13"/>
-          <p:cNvSpPr/>
-          <p:nvPr/>
-        </p:nvSpPr>
-        <p:spPr>
-          <a:xfrm>
-            <a:off x="3657600" y="4617720"/>
-            <a:ext cx="2926080" cy="822960"/>
-          </a:xfrm>
-          <a:prstGeom prst="roundRect">
-            <a:avLst/>
-          </a:prstGeom>
-          <a:solidFill>
-            <a:srgbClr val="DDEBF7"/>
-          </a:solidFill>
-          <a:ln w="15875">
-            <a:solidFill>
-              <a:srgbClr val="404040"/>
-            </a:solidFill>
-          </a:ln>
-          <a:effectLst/>
-        </p:spPr>
-        <p:style>
-          <a:lnRef idx="1">
-            <a:schemeClr val="accent1"/>
-          </a:lnRef>
-          <a:fillRef idx="3">
-            <a:schemeClr val="accent1"/>
-          </a:fillRef>
-          <a:effectRef idx="2">
-            <a:schemeClr val="accent1"/>
-          </a:effectRef>
-          <a:fontRef idx="minor">
-            <a:schemeClr val="lt1"/>
-          </a:fontRef>
-        </p:style>
-        <p:txBody>
-          <a:bodyPr rtlCol="0" anchor="ctr" wrap="square" lIns="45720" rIns="45720" tIns="18288" bIns="18288"/>
-          <a:lstStyle/>
-          <a:p>
-            <a:pPr algn="ctr"/>
-            <a:r>
-              <a:rPr sz="1400" b="1">
-                <a:solidFill>
-                  <a:srgbClr val="000000"/>
-                </a:solidFill>
-                <a:latin typeface="メイリオ"/>
-              </a:rPr>
-              <a:t>親部材集約</a:t>
-            </a:r>
-          </a:p>
-        </p:txBody>
-      </p:sp>
-      <p:sp>
-        <p:nvSpPr>
-          <p:cNvPr id="15" name="Rounded Rectangle 14"/>
-          <p:cNvSpPr/>
-          <p:nvPr/>
-        </p:nvSpPr>
-        <p:spPr>
-          <a:xfrm>
-            <a:off x="3657600" y="5715000"/>
-            <a:ext cx="2926080" cy="822960"/>
-          </a:xfrm>
-          <a:prstGeom prst="roundRect">
-            <a:avLst/>
-          </a:prstGeom>
-          <a:solidFill>
-            <a:srgbClr val="DDEBF7"/>
-          </a:solidFill>
-          <a:ln w="15875">
-            <a:solidFill>
-              <a:srgbClr val="404040"/>
-            </a:solidFill>
-          </a:ln>
-          <a:effectLst/>
-        </p:spPr>
-        <p:style>
-          <a:lnRef idx="1">
-            <a:schemeClr val="accent1"/>
-          </a:lnRef>
-          <a:fillRef idx="3">
-            <a:schemeClr val="accent1"/>
-          </a:fillRef>
-          <a:effectRef idx="2">
-            <a:schemeClr val="accent1"/>
-          </a:effectRef>
-          <a:fontRef idx="minor">
-            <a:schemeClr val="lt1"/>
-          </a:fontRef>
-        </p:style>
-        <p:txBody>
-          <a:bodyPr rtlCol="0" anchor="ctr" wrap="square" lIns="45720" rIns="45720" tIns="18288" bIns="18288"/>
-          <a:lstStyle/>
-          <a:p>
-            <a:pPr algn="ctr"/>
-            <a:r>
-              <a:rPr sz="1400" b="1">
-                <a:solidFill>
-                  <a:srgbClr val="000000"/>
-                </a:solidFill>
-                <a:latin typeface="メイリオ"/>
-              </a:rPr>
               <a:t>MAからラベル再印刷</a:t>
             </a:r>
           </a:p>
@@ -3849,8 +3849,8 @@
         </p:nvCxnSpPr>
         <p:spPr>
           <a:xfrm>
-            <a:off x="2834640" y="1234440"/>
-            <a:ext cx="548640" cy="0"/>
+            <a:off x="2377440" y="1097280"/>
+            <a:ext cx="640080" cy="0"/>
           </a:xfrm>
           <a:prstGeom prst="bentConnector3">
             <a:avLst/>
@@ -3885,8 +3885,8 @@
         </p:nvCxnSpPr>
         <p:spPr>
           <a:xfrm>
-            <a:off x="4297680" y="685800"/>
-            <a:ext cx="4480560" cy="160020"/>
+            <a:off x="3794760" y="1645920"/>
+            <a:ext cx="0" cy="365760"/>
           </a:xfrm>
           <a:prstGeom prst="bentConnector3">
             <a:avLst/>
@@ -3921,7 +3921,7 @@
         </p:nvSpPr>
         <p:spPr>
           <a:xfrm>
-            <a:off x="6172200" y="601218"/>
+            <a:off x="3429000" y="1664208"/>
             <a:ext cx="731520" cy="274320"/>
           </a:xfrm>
           <a:prstGeom prst="rect">
@@ -3956,8 +3956,8 @@
         </p:nvCxnSpPr>
         <p:spPr>
           <a:xfrm>
-            <a:off x="4297680" y="1783080"/>
-            <a:ext cx="2286000" cy="45720"/>
+            <a:off x="4572000" y="1097280"/>
+            <a:ext cx="2103120" cy="0"/>
           </a:xfrm>
           <a:prstGeom prst="bentConnector3">
             <a:avLst/>
@@ -3992,7 +3992,7 @@
         </p:nvSpPr>
         <p:spPr>
           <a:xfrm>
-            <a:off x="5074920" y="1641348"/>
+            <a:off x="5257800" y="932688"/>
             <a:ext cx="731520" cy="274320"/>
           </a:xfrm>
           <a:prstGeom prst="rect">
@@ -4026,9 +4026,9 @@
           <p:nvPr/>
         </p:nvCxnSpPr>
         <p:spPr>
-          <a:xfrm>
-            <a:off x="6583680" y="1828800"/>
-            <a:ext cx="2194560" cy="160020"/>
+          <a:xfrm flipH="1">
+            <a:off x="6492240" y="1645920"/>
+            <a:ext cx="914400" cy="365760"/>
           </a:xfrm>
           <a:prstGeom prst="bentConnector3">
             <a:avLst/>
@@ -4063,7 +4063,7 @@
         </p:nvSpPr>
         <p:spPr>
           <a:xfrm>
-            <a:off x="7315200" y="1744218"/>
+            <a:off x="6583680" y="1664208"/>
             <a:ext cx="731520" cy="274320"/>
           </a:xfrm>
           <a:prstGeom prst="rect">
@@ -4098,8 +4098,8 @@
         </p:nvCxnSpPr>
         <p:spPr>
           <a:xfrm>
-            <a:off x="6583680" y="2926080"/>
-            <a:ext cx="2194560" cy="274320"/>
+            <a:off x="7406640" y="1645920"/>
+            <a:ext cx="1554480" cy="365760"/>
           </a:xfrm>
           <a:prstGeom prst="bentConnector3">
             <a:avLst/>
@@ -4134,7 +4134,7 @@
         </p:nvSpPr>
         <p:spPr>
           <a:xfrm>
-            <a:off x="7315200" y="2898648"/>
+            <a:off x="7818120" y="1664208"/>
             <a:ext cx="731520" cy="274320"/>
           </a:xfrm>
           <a:prstGeom prst="rect">
@@ -4168,9 +4168,9 @@
           <p:nvPr/>
         </p:nvCxnSpPr>
         <p:spPr>
-          <a:xfrm flipV="1">
-            <a:off x="2834640" y="845820"/>
-            <a:ext cx="5943600" cy="1531620"/>
+          <a:xfrm>
+            <a:off x="2377440" y="2377440"/>
+            <a:ext cx="640080" cy="0"/>
           </a:xfrm>
           <a:prstGeom prst="bentConnector3">
             <a:avLst/>
@@ -4205,8 +4205,8 @@
         </p:nvCxnSpPr>
         <p:spPr>
           <a:xfrm>
-            <a:off x="2834640" y="3931920"/>
-            <a:ext cx="822960" cy="0"/>
+            <a:off x="2377440" y="3611880"/>
+            <a:ext cx="640080" cy="0"/>
           </a:xfrm>
           <a:prstGeom prst="bentConnector3">
             <a:avLst/>
@@ -4241,8 +4241,8 @@
         </p:nvCxnSpPr>
         <p:spPr>
           <a:xfrm>
-            <a:off x="2834640" y="5029200"/>
-            <a:ext cx="822960" cy="0"/>
+            <a:off x="2377440" y="4709160"/>
+            <a:ext cx="640080" cy="0"/>
           </a:xfrm>
           <a:prstGeom prst="bentConnector3">
             <a:avLst/>
@@ -4277,8 +4277,8 @@
         </p:nvCxnSpPr>
         <p:spPr>
           <a:xfrm>
-            <a:off x="2834640" y="6126480"/>
-            <a:ext cx="822960" cy="0"/>
+            <a:off x="2377440" y="5806440"/>
+            <a:ext cx="640080" cy="0"/>
           </a:xfrm>
           <a:prstGeom prst="bentConnector3">
             <a:avLst/>

</xml_diff>